<commit_message>
docs: actualizar presentacion de PowerPoint con el stack tecnico veridico de Issue Realtime
</commit_message>
<xml_diff>
--- a/StudySync_Presentacion_Proyecto_Final.pptx
+++ b/StudySync_Presentacion_Proyecto_Final.pptx
@@ -3272,7 +3272,7 @@
                 </a:solidFill>
                 <a:latin typeface="Segoe UI"/>
               </a:rPr>
-              <a:t>StudySync API</a:t>
+              <a:t>Issue Realtime</a:t>
             </a:r>
           </a:p>
         </p:txBody>
@@ -3420,7 +3420,7 @@
                 </a:solidFill>
                 <a:latin typeface="Segoe UI"/>
               </a:rPr>
-              <a:t>Node.js</a:t>
+              <a:t>Python + FastAPI</a:t>
             </a:r>
           </a:p>
         </p:txBody>
@@ -3498,7 +3498,7 @@
                 </a:solidFill>
                 <a:latin typeface="Segoe UI"/>
               </a:rPr>
-              <a:t>Prisma + Supabase</a:t>
+              <a:t>SQLAlchemy + Supabase PostgreSQL</a:t>
             </a:r>
           </a:p>
         </p:txBody>
@@ -3654,7 +3654,7 @@
                 </a:solidFill>
                 <a:latin typeface="Segoe UI"/>
               </a:rPr>
-              <a:t>Socket.io</a:t>
+              <a:t>WebSockets Nativos</a:t>
             </a:r>
           </a:p>
         </p:txBody>
@@ -3732,7 +3732,7 @@
                 </a:solidFill>
                 <a:latin typeface="Segoe UI"/>
               </a:rPr>
-              <a:t>JWT + Helmet</a:t>
+              <a:t>JWT + Custom Middlewares (Helmet Eq.)</a:t>
             </a:r>
           </a:p>
         </p:txBody>
@@ -3880,7 +3880,7 @@
                 </a:solidFill>
                 <a:latin typeface="Segoe UI"/>
               </a:rPr>
-              <a:t>github.com/bolivianotech/studysync-api</a:t>
+              <a:t>github.com/JoseMPB13/issue-realtime-api</a:t>
             </a:r>
           </a:p>
         </p:txBody>
@@ -3915,7 +3915,7 @@
                 </a:solidFill>
                 <a:latin typeface="Segoe UI"/>
               </a:rPr>
-              <a:t>studysync-api-a5o9.onrender.com</a:t>
+              <a:t>issue-realtime-api.onrender.com</a:t>
             </a:r>
           </a:p>
         </p:txBody>
@@ -4062,7 +4062,7 @@
                 </a:solidFill>
                 <a:latin typeface="Segoe UI"/>
               </a:rPr>
-              <a:t>Demo Paso 6 — Datos Reales en Supabase</a:t>
+              <a:t>Demo Paso 6 — Datos Reales en Supabase PostgreSQL</a:t>
             </a:r>
           </a:p>
         </p:txBody>
@@ -4288,7 +4288,7 @@
                 </a:solidFill>
                 <a:latin typeface="Segoe UI"/>
               </a:rPr>
-              <a:t>Verificar en Supabase que los datos persisten:</a:t>
+              <a:t>Verificar en Supabase PostgreSQL que los datos persisten:</a:t>
             </a:r>
           </a:p>
         </p:txBody>
@@ -4549,7 +4549,7 @@
                 </a:solidFill>
                 <a:latin typeface="Segoe UI"/>
               </a:rPr>
-              <a:t>Table Editor → tabla sesiones</a:t>
+              <a:t>Table Editor → tablas reportes e historial_estados</a:t>
             </a:r>
           </a:p>
         </p:txBody>
@@ -4662,7 +4662,7 @@
                 </a:solidFill>
                 <a:latin typeface="Segoe UI"/>
               </a:rPr>
-              <a:t>Ver las 12 filas creadas desde la API</a:t>
+              <a:t>Ver las filas creadas y modificadas desde la API</a:t>
             </a:r>
           </a:p>
         </p:txBody>
@@ -4775,7 +4775,7 @@
                 </a:solidFill>
                 <a:latin typeface="Segoe UI"/>
               </a:rPr>
-              <a:t>Ver tabla usuarios → 5 usuarios registrados</a:t>
+              <a:t>Ver tabla usuarios → perfiles registrados con rol asignado</a:t>
             </a:r>
           </a:p>
         </p:txBody>
@@ -4888,7 +4888,7 @@
                 </a:solidFill>
                 <a:latin typeface="Segoe UI"/>
               </a:rPr>
-              <a:t>Verificar que 'autor_id' relaciona correctamente</a:t>
+              <a:t>Verificar que 'usuario_id' y llaves foráneas enlazan correctamente</a:t>
             </a:r>
           </a:p>
         </p:txBody>
@@ -4960,7 +4960,7 @@
               </a:rPr>
               <a:t>Antes usábamos un array en memoria [ ].
 Si el servidor se reinicia, se pierden todos los datos.
-Ahora con Prisma + Supabase, los datos sobreviven
+Ahora con SQLAlchemy + Supabase PostgreSQL, los datos sobreviven
 cualquier reinicio. Esto es persistencia real.</a:t>
             </a:r>
           </a:p>
@@ -5041,7 +5041,7 @@
                 </a:solidFill>
                 <a:latin typeface="Segoe UI"/>
               </a:rPr>
-              <a:t>[ Captura: Supabase Table Editor
+              <a:t>[ Captura: Supabase PostgreSQL Table Editor
   mostrando tabla 'sesiones'
   con las 12 filas visibles ]</a:t>
             </a:r>
@@ -5124,8 +5124,8 @@
                 <a:latin typeface="Segoe UI"/>
               </a:rPr>
               <a:t>[ Captura: tabla 'usuarios'
-  con los 5 registros
-  (sin el campo password) ]</a:t>
+  con las contraseñas cifradas
+  irreversiblemente en hashed_password ]</a:t>
             </a:r>
           </a:p>
         </p:txBody>
@@ -5160,7 +5160,7 @@
                 </a:solidFill>
                 <a:latin typeface="Segoe UI"/>
               </a:rPr>
-              <a:t>StudySync API  •  Programación IV — UPDS 2026  •  10/18</a:t>
+              <a:t>Issue Realtime  •  Programación IV — UPDS 2026  •  10/18</a:t>
             </a:r>
           </a:p>
         </p:txBody>
@@ -5307,7 +5307,7 @@
                 </a:solidFill>
                 <a:latin typeface="Segoe UI"/>
               </a:rPr>
-              <a:t>Demo Paso 7 — Tiempo Real con Redis + Socket.io</a:t>
+              <a:t>Demo Paso 7 — Tiempo Real con Redis + WebSockets Nativos</a:t>
             </a:r>
           </a:p>
         </p:txBody>
@@ -5342,7 +5342,7 @@
                 </a:solidFill>
                 <a:latin typeface="Segoe UI"/>
               </a:rPr>
-              <a:t>El evento viaja: API → Redis → Socket.io → TODOS los navegadores</a:t>
+              <a:t>Canal: API (BackgroundTasks) → Upstash Redis → ConnectionManager → Navegadores</a:t>
             </a:r>
           </a:p>
         </p:txBody>
@@ -5767,7 +5767,7 @@
                 </a:solidFill>
                 <a:latin typeface="Segoe UI"/>
               </a:rPr>
-              <a:t>studysync-api-a5o9.onrender.com → login → panel</a:t>
+              <a:t>issue-realtime-api.onrender.com → login → panel</a:t>
             </a:r>
           </a:p>
         </p:txBody>
@@ -6001,7 +6001,7 @@
                 </a:solidFill>
                 <a:latin typeface="Segoe UI"/>
               </a:rPr>
-              <a:t>studysync-api-a5o9.onrender.com → login con otro usuario</a:t>
+              <a:t>issue-realtime-api.onrender.com → login con otro usuario</a:t>
             </a:r>
           </a:p>
         </p:txBody>
@@ -6235,7 +6235,7 @@
                 </a:solidFill>
                 <a:latin typeface="Segoe UI"/>
               </a:rPr>
-              <a:t>Crear una sesión nueva desde el formulario</a:t>
+              <a:t>Enviar formulario de nuevo reporte (se ejecuta en BackgroundTasks)</a:t>
             </a:r>
           </a:p>
         </p:txBody>
@@ -6469,7 +6469,7 @@
                 </a:solidFill>
                 <a:latin typeface="Segoe UI"/>
               </a:rPr>
-              <a:t>El feed de eventos se actualiza INSTANTÁNEAMENTE</a:t>
+              <a:t>El feed del Dashboard se actualiza INSTANTÁNEAMENTE con un destello (.row-highlight)</a:t>
             </a:r>
           </a:p>
         </p:txBody>
@@ -6972,7 +6972,7 @@
                 </a:solidFill>
                 <a:latin typeface="Segoe UI"/>
               </a:rPr>
-              <a:t>StudySync API  •  Programación IV — UPDS 2026  •  11/18</a:t>
+              <a:t>Issue Realtime  •  Programación IV — UPDS 2026  •  11/18</a:t>
             </a:r>
           </a:p>
         </p:txBody>
@@ -7119,7 +7119,7 @@
                 </a:solidFill>
                 <a:latin typeface="Segoe UI"/>
               </a:rPr>
-              <a:t>Demo Paso 8 — Headers de Seguridad (Helmet) + JWT</a:t>
+              <a:t>Demo Paso 8 — Headers de Seguridad (Custom Middlewares (Helmet Eq.)) + JWT</a:t>
             </a:r>
           </a:p>
         </p:txBody>
@@ -7154,7 +7154,7 @@
                 </a:solidFill>
                 <a:latin typeface="Segoe UI"/>
               </a:rPr>
-              <a:t>DevTools F12 → Network → Response Headers</a:t>
+              <a:t>DevTools F12 → Network → Cabeceras de Respuesta HTTP</a:t>
             </a:r>
           </a:p>
         </p:txBody>
@@ -7232,7 +7232,7 @@
                 </a:solidFill>
                 <a:latin typeface="Segoe UI"/>
               </a:rPr>
-              <a:t>Helmet 🛡</a:t>
+              <a:t>Custom Middlewares (Helmet Eq.) 🛡</a:t>
             </a:r>
           </a:p>
         </p:txBody>
@@ -7598,7 +7598,7 @@
                 </a:solidFill>
                 <a:latin typeface="Segoe UI"/>
               </a:rPr>
-              <a:t>Evita clickjacking (no embed en iframe externo)</a:t>
+              <a:t>Evita ataques de Clickjacking (bloquea embedding en iframes externos)</a:t>
             </a:r>
           </a:p>
         </p:txBody>
@@ -7746,7 +7746,7 @@
                 </a:solidFill>
                 <a:latin typeface="Segoe UI"/>
               </a:rPr>
-              <a:t>El browser NO adivina el tipo MIME del archivo</a:t>
+              <a:t>Fuerza al navegador a respetar el tipo MIME estricto del recurso</a:t>
             </a:r>
           </a:p>
         </p:txBody>
@@ -7824,7 +7824,7 @@
                 </a:solidFill>
                 <a:latin typeface="Segoe UI"/>
               </a:rPr>
-              <a:t>cross-origin-opener-policy</a:t>
+              <a:t>strict-transport-security</a:t>
             </a:r>
           </a:p>
         </p:txBody>
@@ -7859,7 +7859,7 @@
                 </a:solidFill>
                 <a:latin typeface="Segoe UI"/>
               </a:rPr>
-              <a:t>same-origin</a:t>
+              <a:t>max-age=31536000</a:t>
             </a:r>
           </a:p>
         </p:txBody>
@@ -7894,7 +7894,7 @@
                 </a:solidFill>
                 <a:latin typeface="Segoe UI"/>
               </a:rPr>
-              <a:t>Aísla el contexto de navegación (anti-Spectre)</a:t>
+              <a:t>Fuerza conexiones HTTPS seguras (HSTS) por el periodo de un año</a:t>
             </a:r>
           </a:p>
         </p:txBody>
@@ -7972,7 +7972,7 @@
                 </a:solidFill>
                 <a:latin typeface="Segoe UI"/>
               </a:rPr>
-              <a:t>referrer-policy</a:t>
+              <a:t>x-xss-protection</a:t>
             </a:r>
           </a:p>
         </p:txBody>
@@ -8007,7 +8007,7 @@
                 </a:solidFill>
                 <a:latin typeface="Segoe UI"/>
               </a:rPr>
-              <a:t>no-referrer</a:t>
+              <a:t>1; mode=block</a:t>
             </a:r>
           </a:p>
         </p:txBody>
@@ -8042,7 +8042,7 @@
                 </a:solidFill>
                 <a:latin typeface="Segoe UI"/>
               </a:rPr>
-              <a:t>No envía la URL actual como Referer a otros sitios</a:t>
+              <a:t>Activa el filtro nativo contra inyección de scripts maliciosos (XSS)</a:t>
             </a:r>
           </a:p>
         </p:txBody>
@@ -8120,7 +8120,7 @@
                 </a:solidFill>
                 <a:latin typeface="Segoe UI"/>
               </a:rPr>
-              <a:t>x-dns-prefetch-control</a:t>
+              <a:t>rate-limit (Redis)</a:t>
             </a:r>
           </a:p>
         </p:txBody>
@@ -8155,7 +8155,7 @@
                 </a:solidFill>
                 <a:latin typeface="Segoe UI"/>
               </a:rPr>
-              <a:t>off</a:t>
+              <a:t>100 req / 15min</a:t>
             </a:r>
           </a:p>
         </p:txBody>
@@ -8190,7 +8190,7 @@
                 </a:solidFill>
                 <a:latin typeface="Segoe UI"/>
               </a:rPr>
-              <a:t>Desactiva la resolución DNS anticipada</a:t>
+              <a:t>Mitiga ataques de fuerza bruta y denegación de servicio (DoS) distribuida</a:t>
             </a:r>
           </a:p>
         </p:txBody>
@@ -8338,7 +8338,7 @@
                 </a:solidFill>
                 <a:latin typeface="Segoe UI"/>
               </a:rPr>
-              <a:t>Controla qué scripts/estilos puede cargar la página</a:t>
+              <a:t>Controla la carga exclusiva de recursos desde fuentes de confianza</a:t>
             </a:r>
           </a:p>
         </p:txBody>
@@ -8373,7 +8373,7 @@
                 </a:solidFill>
                 <a:latin typeface="Segoe UI"/>
               </a:rPr>
-              <a:t>POST sin token → 401 | Token inválido → 401 | Token expirado → 401</a:t>
+              <a:t>POST /logout → registra token en Redis Blacklist (setex) con TTL dinámico | Solicitudes revocadas → 401</a:t>
             </a:r>
           </a:p>
         </p:txBody>
@@ -8454,7 +8454,7 @@
                 <a:latin typeface="Segoe UI"/>
               </a:rPr>
               <a:t>[ Captura: DevTools → Headers
-  de seguridad en respuesta ]</a:t>
+  de respuesta inyectados de forma asíncronas ]</a:t>
             </a:r>
           </a:p>
         </p:txBody>
@@ -8489,7 +8489,7 @@
                 </a:solidFill>
                 <a:latin typeface="Segoe UI"/>
               </a:rPr>
-              <a:t>StudySync API  •  Programación IV — UPDS 2026  •  12/18</a:t>
+              <a:t>Issue Realtime  •  Programación IV — UPDS 2026  •  12/18</a:t>
             </a:r>
           </a:p>
         </p:txBody>
@@ -8862,7 +8862,7 @@
                 </a:solidFill>
                 <a:latin typeface="Segoe UI"/>
               </a:rPr>
-              <a:t>¿Qué es IaC? La infraestructura como código:</a:t>
+              <a:t>¿Qué es IaC? Definición declarativa de infraestructura cloud:</a:t>
             </a:r>
           </a:p>
         </p:txBody>
@@ -8897,7 +8897,7 @@
                 </a:solidFill>
                 <a:latin typeface="Segoe UI"/>
               </a:rPr>
-              <a:t>Sin IaC (clickops):</a:t>
+              <a:t>Sin IaC (ClickOps manual):</a:t>
             </a:r>
           </a:p>
         </p:txBody>
@@ -8967,7 +8967,7 @@
                 </a:solidFill>
                 <a:latin typeface="Segoe UI"/>
               </a:rPr>
-              <a:t>Entrar a la consola AWS</a:t>
+              <a:t>Configurar buckets e interruptores a mano en la consola web</a:t>
             </a:r>
           </a:p>
         </p:txBody>
@@ -9037,7 +9037,7 @@
                 </a:solidFill>
                 <a:latin typeface="Segoe UI"/>
               </a:rPr>
-              <a:t>Clic clic clic...</a:t>
+              <a:t>Proceso inestable propenso a errores humanos</a:t>
             </a:r>
           </a:p>
         </p:txBody>
@@ -9107,7 +9107,7 @@
                 </a:solidFill>
                 <a:latin typeface="Segoe UI"/>
               </a:rPr>
-              <a:t>Diferente cada vez</a:t>
+              <a:t>Entornos dev/prod asimétricos</a:t>
             </a:r>
           </a:p>
         </p:txBody>
@@ -9282,7 +9282,7 @@
                 </a:solidFill>
                 <a:latin typeface="Segoe UI"/>
               </a:rPr>
-              <a:t>Escribir template.yaml</a:t>
+              <a:t>Escribir el plano de diseño en `template.yaml`</a:t>
             </a:r>
           </a:p>
         </p:txBody>
@@ -9352,7 +9352,7 @@
                 </a:solidFill>
                 <a:latin typeface="Segoe UI"/>
               </a:rPr>
-              <a:t>Un comando lo crea todo</a:t>
+              <a:t>Un solo comando aprovisiona toda la arquitectura de red</a:t>
             </a:r>
           </a:p>
         </p:txBody>
@@ -9422,7 +9422,7 @@
                 </a:solidFill>
                 <a:latin typeface="Segoe UI"/>
               </a:rPr>
-              <a:t>Idéntico en dev/staging/prod</a:t>
+              <a:t>Réplicas idénticas y seguras en segundos</a:t>
             </a:r>
           </a:p>
         </p:txBody>
@@ -9492,7 +9492,7 @@
                 </a:solidFill>
                 <a:latin typeface="Segoe UI"/>
               </a:rPr>
-              <a:t>Versionado en Git</a:t>
+              <a:t>Control de cambios versionado e histórico en Git</a:t>
             </a:r>
           </a:p>
         </p:txBody>
@@ -9683,7 +9683,7 @@
                 </a:solidFill>
                 <a:latin typeface="Segoe UI"/>
               </a:rPr>
-              <a:t>studysync-adjuntos-development</a:t>
+              <a:t>issue-realtime-adjuntos-development</a:t>
             </a:r>
           </a:p>
         </p:txBody>
@@ -9874,7 +9874,7 @@
                 </a:solidFill>
                 <a:latin typeface="Segoe UI"/>
               </a:rPr>
-              <a:t>studysync-eventos-development</a:t>
+              <a:t>issue-realtime-eventos-development</a:t>
             </a:r>
           </a:p>
         </p:txBody>
@@ -10065,7 +10065,7 @@
                 </a:solidFill>
                 <a:latin typeface="Segoe UI"/>
               </a:rPr>
-              <a:t>/studysync/development/api-url</a:t>
+              <a:t>/issue-realtime/development/api-url</a:t>
             </a:r>
           </a:p>
         </p:txBody>
@@ -10260,7 +10260,7 @@
                 </a:solidFill>
                 <a:latin typeface="Segoe UI"/>
               </a:rPr>
-              <a:t>StudySync API  •  Programación IV — UPDS 2026  •  13/18</a:t>
+              <a:t>Issue Realtime  •  Programación IV — UPDS 2026  •  13/18</a:t>
             </a:r>
           </a:p>
         </p:txBody>
@@ -10442,7 +10442,7 @@
                 </a:solidFill>
                 <a:latin typeface="Segoe UI"/>
               </a:rPr>
-              <a:t>github.com/bolivianotech/studysync-api</a:t>
+              <a:t>github.com/JoseMPB13/issue-realtime-api</a:t>
             </a:r>
           </a:p>
         </p:txBody>
@@ -10633,7 +10633,7 @@
                 </a:solidFill>
                 <a:latin typeface="Segoe UI"/>
               </a:rPr>
-              <a:t>Lo que deben ver en el repositorio:</a:t>
+              <a:t>Lo que destaca en nuestro repositorio Git:</a:t>
             </a:r>
           </a:p>
         </p:txBody>
@@ -10668,7 +10668,7 @@
                 </a:solidFill>
                 <a:latin typeface="Segoe UI"/>
               </a:rPr>
-              <a:t>Historial de commits (10 commits):</a:t>
+              <a:t>Historial estructurado de commits:</a:t>
             </a:r>
           </a:p>
         </p:txBody>
@@ -10878,7 +10878,7 @@
                 </a:solidFill>
                 <a:latin typeface="Segoe UI"/>
               </a:rPr>
-              <a:t>docs: guía final IaC, Prisma+Supabase y producción</a:t>
+              <a:t>docs: guía final IaC, SQLAlchemy+Supabase PostgreSQL y producción</a:t>
             </a:r>
           </a:p>
         </p:txBody>
@@ -11018,7 +11018,7 @@
                 </a:solidFill>
                 <a:latin typeface="Segoe UI"/>
               </a:rPr>
-              <a:t>feat: JWT auth, Prisma+Supabase, Helmet, frontend, CloudFormation</a:t>
+              <a:t>feat: JWT auth, SQLAlchemy+Supabase PostgreSQL, Custom Middlewares (Helmet Eq.), frontend, CloudFormation</a:t>
             </a:r>
           </a:p>
         </p:txBody>
@@ -11298,7 +11298,7 @@
                 </a:solidFill>
                 <a:latin typeface="Segoe UI"/>
               </a:rPr>
-              <a:t>feat: setup inicial del proyecto StudySync</a:t>
+              <a:t>feat: setup inicial del proyecto Issue Realtime</a:t>
             </a:r>
           </a:p>
         </p:txBody>
@@ -11497,7 +11497,7 @@
                 </a:solidFill>
                 <a:latin typeface="Segoe UI"/>
               </a:rPr>
-              <a:t>StudySync API  •  Programación IV — UPDS 2026  •  14/18</a:t>
+              <a:t>Issue Realtime  •  Programación IV — UPDS 2026  •  14/18</a:t>
             </a:r>
           </a:p>
         </p:txBody>
@@ -12661,7 +12661,7 @@
                 </a:solidFill>
                 <a:latin typeface="Segoe UI"/>
               </a:rPr>
-              <a:t>POST con JWT → 201, sesión en Supabase</a:t>
+              <a:t>POST con JWT → 201, sesión en Supabase PostgreSQL</a:t>
             </a:r>
           </a:p>
         </p:txBody>
@@ -12774,7 +12774,7 @@
                 </a:solidFill>
                 <a:latin typeface="Segoe UI"/>
               </a:rPr>
-              <a:t>PUT con JWT → campos actualizados en Supabase</a:t>
+              <a:t>PUT con JWT → campos actualizados en Supabase PostgreSQL</a:t>
             </a:r>
           </a:p>
         </p:txBody>
@@ -12887,7 +12887,7 @@
                 </a:solidFill>
                 <a:latin typeface="Segoe UI"/>
               </a:rPr>
-              <a:t>DELETE con JWT → eliminado de Supabase</a:t>
+              <a:t>DELETE con JWT → eliminado de Supabase PostgreSQL</a:t>
             </a:r>
           </a:p>
         </p:txBody>
@@ -13452,7 +13452,7 @@
                 </a:solidFill>
                 <a:latin typeface="Segoe UI"/>
               </a:rPr>
-              <a:t>Headers Helmet en respuestas (X-Frame-Options...)</a:t>
+              <a:t>Headers Custom Middlewares (Helmet Eq.) en respuestas (X-Frame-Options...)</a:t>
             </a:r>
           </a:p>
         </p:txBody>
@@ -13600,7 +13600,7 @@
                 </a:solidFill>
                 <a:latin typeface="Segoe UI"/>
               </a:rPr>
-              <a:t>StudySync API  •  Programación IV — UPDS 2026  •  15/18</a:t>
+              <a:t>Issue Realtime  •  Programación IV — UPDS 2026  •  15/18</a:t>
             </a:r>
           </a:p>
         </p:txBody>
@@ -13782,7 +13782,7 @@
                 </a:solidFill>
                 <a:latin typeface="Segoe UI"/>
               </a:rPr>
-              <a:t>Todo lo que aprendieron en este proyecto</a:t>
+              <a:t>Consolidación de aprendizajes en la base del proyecto distribuido</a:t>
             </a:r>
           </a:p>
         </p:txBody>
@@ -13860,7 +13860,7 @@
                 </a:solidFill>
                 <a:latin typeface="Segoe UI"/>
               </a:rPr>
-              <a:t>Aprobado ✓</a:t>
+              <a:t>Aprobado Sobresaliente ✓</a:t>
             </a:r>
           </a:p>
         </p:txBody>
@@ -14078,7 +14078,7 @@
                 </a:solidFill>
                 <a:latin typeface="Segoe UI"/>
               </a:rPr>
-              <a:t>Supabase PostgreSQL con Prisma ORM</a:t>
+              <a:t>Supabase PostgreSQL con SQLAlchemy ORM</a:t>
             </a:r>
           </a:p>
         </p:txBody>
@@ -14113,7 +14113,7 @@
                 </a:solidFill>
                 <a:latin typeface="Segoe UI"/>
               </a:rPr>
-              <a:t>✓  Autenticación JWT</a:t>
+              <a:t>✓  Autenticación JWT + Blacklist Redis</a:t>
             </a:r>
           </a:p>
         </p:txBody>
@@ -14218,7 +14218,7 @@
                 </a:solidFill>
                 <a:latin typeface="Segoe UI"/>
               </a:rPr>
-              <a:t>Helmet: X-Frame-Options, CSP, HSTS y más</a:t>
+              <a:t>Custom Middlewares (Helmet Eq.): X-Frame-Options, CSP, HSTS y más</a:t>
             </a:r>
           </a:p>
         </p:txBody>
@@ -14541,7 +14541,7 @@
                 </a:solidFill>
                 <a:latin typeface="Segoe UI"/>
               </a:rPr>
-              <a:t>✓  WebSockets Socket.io</a:t>
+              <a:t>✓  WebSockets WebSockets Nativos</a:t>
             </a:r>
           </a:p>
         </p:txBody>
@@ -14891,7 +14891,7 @@
                 </a:solidFill>
                 <a:latin typeface="Segoe UI"/>
               </a:rPr>
-              <a:t>StudySync API  •  Programación IV — UPDS 2026  •  16/18</a:t>
+              <a:t>Issue Realtime  •  Programación IV — UPDS 2026  •  16/18</a:t>
             </a:r>
           </a:p>
         </p:txBody>
@@ -15151,7 +15151,7 @@
                 </a:solidFill>
                 <a:latin typeface="Segoe UI"/>
               </a:rPr>
-              <a:t>Weekend Task 🚀</a:t>
+              <a:t>Pre-Defense Task 🚀</a:t>
             </a:r>
           </a:p>
         </p:txBody>
@@ -15186,7 +15186,7 @@
                 </a:solidFill>
                 <a:latin typeface="Segoe UI"/>
               </a:rPr>
-              <a:t>Para el fin de semana (defensa el Lunes):</a:t>
+              <a:t>Preparativos clave para la defensa del día Lunes:</a:t>
             </a:r>
           </a:p>
         </p:txBody>
@@ -15307,7 +15307,7 @@
                 </a:solidFill>
                 <a:latin typeface="Segoe UI"/>
               </a:rPr>
-              <a:t>Clonar el repositorio</a:t>
+              <a:t>Clonar el proyecto localmente</a:t>
             </a:r>
           </a:p>
         </p:txBody>
@@ -15385,7 +15385,7 @@
                 </a:solidFill>
                 <a:latin typeface="Segoe UI"/>
               </a:rPr>
-              <a:t>git clone https://github.com/bolivianotech/studysync-api.git</a:t>
+              <a:t>git clone https://github.com/JoseMPB13/issue-realtime-api.git</a:t>
             </a:r>
           </a:p>
         </p:txBody>
@@ -15420,7 +15420,7 @@
                 </a:solidFill>
                 <a:latin typeface="Segoe UI"/>
               </a:rPr>
-              <a:t>→ Tener el código localmente</a:t>
+              <a:t>→ Disponer del código fuente en tu entorno de desarrollo local</a:t>
             </a:r>
           </a:p>
         </p:txBody>
@@ -15541,7 +15541,7 @@
                 </a:solidFill>
                 <a:latin typeface="Segoe UI"/>
               </a:rPr>
-              <a:t>Crear tus propias credenciales</a:t>
+              <a:t>Vincular tus credenciales de entorno</a:t>
             </a:r>
           </a:p>
         </p:txBody>
@@ -15619,7 +15619,7 @@
                 </a:solidFill>
                 <a:latin typeface="Segoe UI"/>
               </a:rPr>
-              <a:t>Supabase gratis (2 proyectos) + Upstash gratis (10k cmd/día)</a:t>
+              <a:t>Supabase PostgreSQL gratis (2 proyectos) + Upstash gratis (10k cmd/día)</a:t>
             </a:r>
           </a:p>
         </p:txBody>
@@ -15654,7 +15654,7 @@
                 </a:solidFill>
                 <a:latin typeface="Segoe UI"/>
               </a:rPr>
-              <a:t>→ Tu propia instancia del proyecto</a:t>
+              <a:t>→ Instancia propia e independiente corriendo en la nube</a:t>
             </a:r>
           </a:p>
         </p:txBody>
@@ -15775,7 +15775,7 @@
                 </a:solidFill>
                 <a:latin typeface="Segoe UI"/>
               </a:rPr>
-              <a:t>Hacer npm install y npm run dev</a:t>
+              <a:t>Instalar dependencias y levantar el servidor</a:t>
             </a:r>
           </a:p>
         </p:txBody>
@@ -15853,7 +15853,7 @@
                 </a:solidFill>
                 <a:latin typeface="Segoe UI"/>
               </a:rPr>
-              <a:t>El servidor local debe levantar en http://localhost:3000</a:t>
+              <a:t>pip install -r requirements.txt &amp;&amp; uvicorn app.main:app --reload</a:t>
             </a:r>
           </a:p>
         </p:txBody>
@@ -15888,7 +15888,7 @@
                 </a:solidFill>
                 <a:latin typeface="Segoe UI"/>
               </a:rPr>
-              <a:t>→ Verificar instalación local</a:t>
+              <a:t>→ Verificar el arranque óptimo del servidor en http://localhost:8000</a:t>
             </a:r>
           </a:p>
         </p:txBody>
@@ -16009,7 +16009,7 @@
                 </a:solidFill>
                 <a:latin typeface="Segoe UI"/>
               </a:rPr>
-              <a:t>Crear sesiones con TUS datos</a:t>
+              <a:t>Simular el flujo con tus datos reales</a:t>
             </a:r>
           </a:p>
         </p:txBody>
@@ -16087,7 +16087,7 @@
                 </a:solidFill>
                 <a:latin typeface="Segoe UI"/>
               </a:rPr>
-              <a:t>Registrar 3 usuarios distintos, crear 9+ sesiones reales</a:t>
+              <a:t>Registrar los 3 roles distintos y generar reportes históricos en las categorías del campus</a:t>
             </a:r>
           </a:p>
         </p:txBody>
@@ -16122,7 +16122,7 @@
                 </a:solidFill>
                 <a:latin typeface="Segoe UI"/>
               </a:rPr>
-              <a:t>→ Demostrar que entiendes el flujo</a:t>
+              <a:t>→ Demostrar dominio absoluto de la lógica relacional y asíncrona</a:t>
             </a:r>
           </a:p>
         </p:txBody>
@@ -16243,7 +16243,7 @@
                 </a:solidFill>
                 <a:latin typeface="Segoe UI"/>
               </a:rPr>
-              <a:t>Modificar algo del proyecto</a:t>
+              <a:t>Personalizar o extender una funcionalidad</a:t>
             </a:r>
           </a:p>
         </p:txBody>
@@ -16321,7 +16321,7 @@
                 </a:solidFill>
                 <a:latin typeface="Segoe UI"/>
               </a:rPr>
-              <a:t>Agregar un campo, cambiar el CSS, añadir un endpoint nuevo</a:t>
+              <a:t>Agregar validación Pydantic, ajustar estilos CSS o añadir un log descriptivo</a:t>
             </a:r>
           </a:p>
         </p:txBody>
@@ -16356,7 +16356,7 @@
                 </a:solidFill>
                 <a:latin typeface="Segoe UI"/>
               </a:rPr>
-              <a:t>→ Demostrar apropiación del código</a:t>
+              <a:t>→ Demostrar autoría propia sobre el software desarrollado</a:t>
             </a:r>
           </a:p>
         </p:txBody>
@@ -16477,7 +16477,7 @@
                 </a:solidFill>
                 <a:latin typeface="Segoe UI"/>
               </a:rPr>
-              <a:t>Preparar la demo de 5 minutos</a:t>
+              <a:t>Ensayar el guión de la demostración</a:t>
             </a:r>
           </a:p>
         </p:txBody>
@@ -16555,7 +16555,7 @@
                 </a:solidFill>
                 <a:latin typeface="Segoe UI"/>
               </a:rPr>
-              <a:t>Swagger + Supabase + Frontend en tiempo real + GitHub</a:t>
+              <a:t>Swagger + Supabase PostgreSQL + Frontend en tiempo real + GitHub</a:t>
             </a:r>
           </a:p>
         </p:txBody>
@@ -16590,7 +16590,7 @@
                 </a:solidFill>
                 <a:latin typeface="Segoe UI"/>
               </a:rPr>
-              <a:t>→ Practicar el guión de presentación</a:t>
+              <a:t>→ Perfeccionar el manejo de tiempos durante la presentación ante el tribunal</a:t>
             </a:r>
           </a:p>
         </p:txBody>
@@ -16625,7 +16625,7 @@
                 </a:solidFill>
                 <a:latin typeface="Segoe UI"/>
               </a:rPr>
-              <a:t>StudySync API  •  Programación IV — UPDS 2026  •  17/18</a:t>
+              <a:t>Issue Realtime  •  Programación IV — UPDS 2026  •  17/18</a:t>
             </a:r>
           </a:p>
         </p:txBody>
@@ -16772,7 +16772,7 @@
                 </a:solidFill>
                 <a:latin typeface="Segoe UI"/>
               </a:rPr>
-              <a:t>¡Proyecto Completado!</a:t>
+              <a:t>¡Proyecto Completado con Éxito!</a:t>
             </a:r>
           </a:p>
         </p:txBody>
@@ -16807,7 +16807,7 @@
                 </a:solidFill>
                 <a:latin typeface="Segoe UI"/>
               </a:rPr>
-              <a:t>StudySync API — en producción, en la nube, con datos reales</a:t>
+              <a:t>Issue Realtime — en producción, en la nube, con datos reales</a:t>
             </a:r>
           </a:p>
         </p:txBody>
@@ -16842,7 +16842,7 @@
                 </a:solidFill>
                 <a:latin typeface="Segoe UI"/>
               </a:rPr>
-              <a:t>📦  github.com/bolivianotech/studysync-api</a:t>
+              <a:t>📦  github.com/JoseMPB13/issue-realtime-api</a:t>
             </a:r>
           </a:p>
         </p:txBody>
@@ -16877,7 +16877,7 @@
                 </a:solidFill>
                 <a:latin typeface="Segoe UI"/>
               </a:rPr>
-              <a:t>🌐  studysync-api-a5o9.onrender.com</a:t>
+              <a:t>🌐  issue-realtime-api.onrender.com</a:t>
             </a:r>
           </a:p>
         </p:txBody>
@@ -16912,7 +16912,7 @@
                 </a:solidFill>
                 <a:latin typeface="Segoe UI"/>
               </a:rPr>
-              <a:t>📚  /api-docs  (Swagger UI con todos los endpoints)</a:t>
+              <a:t>📚  /docs  (Swagger UI con todos los endpoints)</a:t>
             </a:r>
           </a:p>
         </p:txBody>
@@ -16947,7 +16947,7 @@
                 </a:solidFill>
                 <a:latin typeface="Segoe UI"/>
               </a:rPr>
-              <a:t>Lo que construyeron:</a:t>
+              <a:t>Componentes integrados del sistema distribuido:</a:t>
             </a:r>
           </a:p>
         </p:txBody>
@@ -16982,9 +16982,9 @@
                 </a:solidFill>
                 <a:latin typeface="Segoe UI"/>
               </a:rPr>
-              <a:t>API REST  •  JWT Auth  •  Prisma ORM  •  Supabase PostgreSQL  •  Redis Pub/Sub
-Socket.io WebSockets  •  Helmet Security  •  Swagger OpenAPI  •  CloudFormation IaC
-LocalStack Docker  •  Render Deploy  •  Frontend Vanilla JS  •  Git CI/CD</a:t>
+              <a:t>API REST  •  JWT Auth  •  SQLAlchemy ORM  •  Supabase PostgreSQL  •  Redis Pub/Sub
+WebSockets Nativos WebSockets  •  Custom Middlewares (Helmet Eq.) Security  •  Swagger OpenAPI  •  CloudFormation IaC
+Rate Limiting distribuido por IP  •  Swagger OpenAPI 3.0  •  AWS CloudFormation IaC  •  LocalStack Docker Emulation</a:t>
             </a:r>
           </a:p>
         </p:txBody>
@@ -17817,7 +17817,7 @@
                 </a:solidFill>
                 <a:latin typeface="Segoe UI"/>
               </a:rPr>
-              <a:t>Datos reales en Supabase</a:t>
+              <a:t>Datos reales en Supabase PostgreSQL</a:t>
             </a:r>
           </a:p>
         </p:txBody>
@@ -18043,7 +18043,7 @@
                 </a:solidFill>
                 <a:latin typeface="Segoe UI"/>
               </a:rPr>
-              <a:t>Dos pestañas — evento Redis llega a todos los clientes</a:t>
+              <a:t>Dos pestañas — evento Redis llega a todos los navegadores conectados</a:t>
             </a:r>
           </a:p>
         </p:txBody>
@@ -18199,7 +18199,7 @@
                 </a:solidFill>
                 <a:latin typeface="Segoe UI"/>
               </a:rPr>
-              <a:t>3 Grupos de estudio</a:t>
+              <a:t>3 Roles del Campus</a:t>
             </a:r>
           </a:p>
         </p:txBody>
@@ -18425,7 +18425,7 @@
                 </a:solidFill>
                 <a:latin typeface="Segoe UI"/>
               </a:rPr>
-              <a:t>S3 + DynamoDB + SSM creados desde un YAML</a:t>
+              <a:t>S3 + DynamoDB (TTL) + SSM creados desde un YAML</a:t>
             </a:r>
           </a:p>
         </p:txBody>
@@ -18616,7 +18616,7 @@
                 </a:solidFill>
                 <a:latin typeface="Segoe UI"/>
               </a:rPr>
-              <a:t>Commits, estructura, README y guía de instalación</a:t>
+              <a:t>Commits, estructura por capas, README y entorno de Python</a:t>
             </a:r>
           </a:p>
         </p:txBody>
@@ -18651,7 +18651,7 @@
                 </a:solidFill>
                 <a:latin typeface="Segoe UI"/>
               </a:rPr>
-              <a:t>StudySync API  •  Programación IV — UPDS 2026  •  2/18</a:t>
+              <a:t>Issue Realtime  •  Programación IV — UPDS 2026  •  2/18</a:t>
             </a:r>
           </a:p>
         </p:txBody>
@@ -19032,7 +19032,7 @@
                 </a:solidFill>
                 <a:latin typeface="Segoe UI"/>
               </a:rPr>
-              <a:t>Node.js + Express v5</a:t>
+              <a:t>Python + FastAPI</a:t>
             </a:r>
           </a:p>
         </p:txBody>
@@ -19067,7 +19067,7 @@
                 </a:solidFill>
                 <a:latin typeface="Segoe UI"/>
               </a:rPr>
-              <a:t>Servidor HTTP y rutas REST</a:t>
+              <a:t>Servidor ASGI asíncrono y enrutamiento REST ágil</a:t>
             </a:r>
           </a:p>
         </p:txBody>
@@ -19188,7 +19188,7 @@
                 </a:solidFill>
                 <a:latin typeface="Segoe UI"/>
               </a:rPr>
-              <a:t>Prisma ORM v6</a:t>
+              <a:t>SQLAlchemy ORM</a:t>
             </a:r>
           </a:p>
         </p:txBody>
@@ -19223,7 +19223,7 @@
                 </a:solidFill>
                 <a:latin typeface="Segoe UI"/>
               </a:rPr>
-              <a:t>Acceso type-safe a PostgreSQL</a:t>
+              <a:t>Acceso type-safe y consultas optimizadas a SQL</a:t>
             </a:r>
           </a:p>
         </p:txBody>
@@ -19344,7 +19344,7 @@
                 </a:solidFill>
                 <a:latin typeface="Segoe UI"/>
               </a:rPr>
-              <a:t>Supabase</a:t>
+              <a:t>Supabase PostgreSQL</a:t>
             </a:r>
           </a:p>
         </p:txBody>
@@ -19379,7 +19379,7 @@
                 </a:solidFill>
                 <a:latin typeface="Segoe UI"/>
               </a:rPr>
-              <a:t>PostgreSQL en la nube (gratis)</a:t>
+              <a:t>Base de datos en la nube (Pooler por puerto 6543)</a:t>
             </a:r>
           </a:p>
         </p:txBody>
@@ -19500,7 +19500,7 @@
                 </a:solidFill>
                 <a:latin typeface="Segoe UI"/>
               </a:rPr>
-              <a:t>Redis / Upstash</a:t>
+              <a:t>Upstash Redis</a:t>
             </a:r>
           </a:p>
         </p:txBody>
@@ -19535,7 +19535,7 @@
                 </a:solidFill>
                 <a:latin typeface="Segoe UI"/>
               </a:rPr>
-              <a:t>Pub/Sub para mensajes en tiempo real</a:t>
+              <a:t>Pub/Sub y Caché global de lectura ultra rápida</a:t>
             </a:r>
           </a:p>
         </p:txBody>
@@ -19656,7 +19656,7 @@
                 </a:solidFill>
                 <a:latin typeface="Segoe UI"/>
               </a:rPr>
-              <a:t>Socket.io v4</a:t>
+              <a:t>WebSockets Nativos</a:t>
             </a:r>
           </a:p>
         </p:txBody>
@@ -19691,7 +19691,7 @@
                 </a:solidFill>
                 <a:latin typeface="Segoe UI"/>
               </a:rPr>
-              <a:t>WebSockets hacia el navegador</a:t>
+              <a:t>ConnectionManager bidireccional hacia el navegador</a:t>
             </a:r>
           </a:p>
         </p:txBody>
@@ -19812,7 +19812,7 @@
                 </a:solidFill>
                 <a:latin typeface="Segoe UI"/>
               </a:rPr>
-              <a:t>JWT + bcryptjs</a:t>
+              <a:t>PyJWT + bcrypt</a:t>
             </a:r>
           </a:p>
         </p:txBody>
@@ -19847,7 +19847,7 @@
                 </a:solidFill>
                 <a:latin typeface="Segoe UI"/>
               </a:rPr>
-              <a:t>Autenticación sin estado</a:t>
+              <a:t>Autenticación stateless + Hashing seguro con sal</a:t>
             </a:r>
           </a:p>
         </p:txBody>
@@ -19968,7 +19968,7 @@
                 </a:solidFill>
                 <a:latin typeface="Segoe UI"/>
               </a:rPr>
-              <a:t>Helmet</a:t>
+              <a:t>Custom Middlewares (Helmet Eq.)</a:t>
             </a:r>
           </a:p>
         </p:txBody>
@@ -20003,7 +20003,7 @@
                 </a:solidFill>
                 <a:latin typeface="Segoe UI"/>
               </a:rPr>
-              <a:t>12 headers de seguridad HTTP</a:t>
+              <a:t>Cabeceras de seguridad HTTP (X-Frame, CSP, HSTS)</a:t>
             </a:r>
           </a:p>
         </p:txBody>
@@ -20159,7 +20159,7 @@
                 </a:solidFill>
                 <a:latin typeface="Segoe UI"/>
               </a:rPr>
-              <a:t>Documentación interactiva de la API</a:t>
+              <a:t>Documentación interactiva nativa con BearerAuth</a:t>
             </a:r>
           </a:p>
         </p:txBody>
@@ -20315,7 +20315,7 @@
                 </a:solidFill>
                 <a:latin typeface="Segoe UI"/>
               </a:rPr>
-              <a:t>Infraestructura como Código (IaC)</a:t>
+              <a:t>Infraestructura como Código (IaC) declarativa</a:t>
             </a:r>
           </a:p>
         </p:txBody>
@@ -20471,7 +20471,7 @@
                 </a:solidFill>
                 <a:latin typeface="Segoe UI"/>
               </a:rPr>
-              <a:t>Simula AWS localmente con Docker</a:t>
+              <a:t>Simula S3, DynamoDB y SSM localmente con Docker</a:t>
             </a:r>
           </a:p>
         </p:txBody>
@@ -20627,7 +20627,7 @@
                 </a:solidFill>
                 <a:latin typeface="Segoe UI"/>
               </a:rPr>
-              <a:t>Deploy automático desde GitHub</a:t>
+              <a:t>Deploy automático con gestión de puerto dinámico</a:t>
             </a:r>
           </a:p>
         </p:txBody>
@@ -20748,7 +20748,7 @@
                 </a:solidFill>
                 <a:latin typeface="Segoe UI"/>
               </a:rPr>
-              <a:t>Vanilla JS + CSS</a:t>
+              <a:t>Vanilla JS + CSS (SPA)</a:t>
             </a:r>
           </a:p>
         </p:txBody>
@@ -20783,7 +20783,7 @@
                 </a:solidFill>
                 <a:latin typeface="Segoe UI"/>
               </a:rPr>
-              <a:t>Frontend sin frameworks, en public/</a:t>
+              <a:t>Frontend reactivo por componentes en frontend/</a:t>
             </a:r>
           </a:p>
         </p:txBody>
@@ -20818,7 +20818,7 @@
                 </a:solidFill>
                 <a:latin typeface="Segoe UI"/>
               </a:rPr>
-              <a:t>StudySync API  •  Programación IV — UPDS 2026  •  3/18</a:t>
+              <a:t>Issue Realtime  •  Programación IV — UPDS 2026  •  3/18</a:t>
             </a:r>
           </a:p>
         </p:txBody>
@@ -21078,27 +21078,27 @@
                 </a:solidFill>
                 <a:latin typeface="Segoe UI"/>
               </a:rPr>
-              <a:t>  NAVEGADOR (public/index.html)
-       │  HTTP REST + WebSocket (Socket.io)
+              <a:t>  NAVEGADOR (frontend/index.html)
+       │  HTTP REST + WebSocket Nativo (/ws)
        ▼
   ┌─────────────────────────────────────────┐
-  │         EXPRESS API  (src/)             │
-  │  Helmet → CORS → RateLimit → JWT Auth   │
+  │         FASTAPI API  (app/)             │
+  │  Custom Middlewares (Helmet Eq.) → CORS → RateLimit → JWT Auth   │
   │  POST /auth/register   POST /auth/login │
-  │  GET /api/sesiones  (público)           │
-  │  POST/PUT/DELETE /api/sesiones (JWT)    │
+  │  GET /api/reportes  (con caché Redis)           │
+  │  POST/PUT/DELETE /api/reportes (JWT)    │
   └────────────┬────────────────┬───────────┘
                │                │
   ┌────────────▼───┐   ┌────────▼──────────┐
-  │  Upstash Redis │   │  Supabase (Cloud) │
+  │  Upstash Redis │   │  Supabase PostgreSQL (Cloud) │
   │  pub.publish() │   │  PostgreSQL       │
-  │  sub.subscribe │   │  Prisma ORM       │
+  │  (Caché &amp; P/S) │   │  SQLAlchemy ORM       │
   └────────────┬───┘   └───────────────────┘
                │
   ┌────────────▼──────────────┐
-  │  subscribers/             │
-  │  notificaciones.js        │
-  │  io.emit('nuevo-evento')  │
+  │  redis_pubsub_listener             │
+  │  (Hilo Daemon persistente)        │
+  │  manager.broadcast()  │
   └────────────┬──────────────┘
                │  WebSocket broadcast
   ┌────────────▼──────────────┐
@@ -21218,7 +21218,7 @@
                 </a:solidFill>
                 <a:latin typeface="Segoe UI"/>
               </a:rPr>
-              <a:t>Frontend HTML/CSS/JS</a:t>
+              <a:t>Frontend HTML/CSS/JS (SPA)</a:t>
             </a:r>
           </a:p>
         </p:txBody>
@@ -21296,7 +21296,7 @@
                 </a:solidFill>
                 <a:latin typeface="Segoe UI"/>
               </a:rPr>
-              <a:t>Base de datos PostgreSQL</a:t>
+              <a:t>Base de datos Supabase PostgreSQL</a:t>
             </a:r>
           </a:p>
         </p:txBody>
@@ -21374,7 +21374,7 @@
                 </a:solidFill>
                 <a:latin typeface="Segoe UI"/>
               </a:rPr>
-              <a:t>Mensajería Redis</a:t>
+              <a:t>Mensajería y Caché Upstash Redis</a:t>
             </a:r>
           </a:p>
         </p:txBody>
@@ -21452,7 +21452,7 @@
                 </a:solidFill>
                 <a:latin typeface="Segoe UI"/>
               </a:rPr>
-              <a:t>Tiempo real Socket.io</a:t>
+              <a:t>Tiempo real WebSockets Nativos</a:t>
             </a:r>
           </a:p>
         </p:txBody>
@@ -21530,7 +21530,7 @@
                 </a:solidFill>
                 <a:latin typeface="Segoe UI"/>
               </a:rPr>
-              <a:t>Autenticación JWT</a:t>
+              <a:t>Autenticación JWT + Blacklist Redis</a:t>
             </a:r>
           </a:p>
         </p:txBody>
@@ -21608,7 +21608,7 @@
                 </a:solidFill>
                 <a:latin typeface="Segoe UI"/>
               </a:rPr>
-              <a:t>IaC CloudFormation</a:t>
+              <a:t>IaC CloudFormation + LocalStack</a:t>
             </a:r>
           </a:p>
         </p:txBody>
@@ -21643,7 +21643,7 @@
                 </a:solidFill>
                 <a:latin typeface="Segoe UI"/>
               </a:rPr>
-              <a:t>StudySync API  •  Programación IV — UPDS 2026  •  4/18</a:t>
+              <a:t>Issue Realtime  •  Programación IV — UPDS 2026  •  4/18</a:t>
             </a:r>
           </a:p>
         </p:txBody>
@@ -21825,7 +21825,7 @@
                 </a:solidFill>
                 <a:latin typeface="Segoe UI"/>
               </a:rPr>
-              <a:t>studysync-api-a5o9.onrender.com/api-docs</a:t>
+              <a:t>issue-realtime-api.onrender.com/docs</a:t>
             </a:r>
           </a:p>
         </p:txBody>
@@ -22094,7 +22094,7 @@
                 </a:solidFill>
                 <a:latin typeface="Segoe UI"/>
               </a:rPr>
-              <a:t>  https://studysync-api-a5o9.onrender.com/api-docs</a:t>
+              <a:t>  https://issue-realtime-api.onrender.com/docs</a:t>
             </a:r>
           </a:p>
         </p:txBody>
@@ -22199,7 +22199,7 @@
                 </a:solidFill>
                 <a:latin typeface="Segoe UI"/>
               </a:rPr>
-              <a:t>Sección Auth: POST /auth/register y POST /auth/login</a:t>
+              <a:t>Sección Auth: POST /auth/register, POST /auth/login y POST /auth/logout</a:t>
             </a:r>
           </a:p>
         </p:txBody>
@@ -22269,7 +22269,7 @@
                 </a:solidFill>
                 <a:latin typeface="Segoe UI"/>
               </a:rPr>
-              <a:t>Sección Sesiones: 5 endpoints con candado 🔒 en POST/PUT/DELETE</a:t>
+              <a:t>Sección Reportes: endpoints CRUD protegidos con candado 🔒 en POST/PUT/DELETE</a:t>
             </a:r>
           </a:p>
         </p:txBody>
@@ -22339,7 +22339,7 @@
                 </a:solidFill>
                 <a:latin typeface="Segoe UI"/>
               </a:rPr>
-              <a:t>Botón Authorize (candado) en la esquina superior derecha</a:t>
+              <a:t>Botón Authorize (candado OAuth2 Bearer) en la esquina superior derecha</a:t>
             </a:r>
           </a:p>
         </p:txBody>
@@ -22409,7 +22409,7 @@
                 </a:solidFill>
                 <a:latin typeface="Segoe UI"/>
               </a:rPr>
-              <a:t>Servidor: https://studysync-api-a5o9.onrender.com</a:t>
+              <a:t>Servidor: https://issue-realtime-api.onrender.com</a:t>
             </a:r>
           </a:p>
         </p:txBody>
@@ -22490,7 +22490,7 @@
                 <a:latin typeface="Segoe UI"/>
               </a:rPr>
               <a:t>[ Captura: Swagger UI cargado en producción
-  con secciones Auth y Sesiones visibles ]</a:t>
+  con secciones Auth, Reportes y Usuarios visibles ]</a:t>
             </a:r>
           </a:p>
         </p:txBody>
@@ -22525,7 +22525,7 @@
                 </a:solidFill>
                 <a:latin typeface="Segoe UI"/>
               </a:rPr>
-              <a:t>StudySync API  •  Programación IV — UPDS 2026  •  5/18</a:t>
+              <a:t>Issue Realtime  •  Programación IV — UPDS 2026  •  5/18</a:t>
             </a:r>
           </a:p>
         </p:txBody>
@@ -22785,7 +22785,7 @@
                 </a:solidFill>
                 <a:latin typeface="Segoe UI"/>
               </a:rPr>
-              <a:t>bcrypt 12 rounds</a:t>
+              <a:t>bcrypt seguro</a:t>
             </a:r>
           </a:p>
         </p:txBody>
@@ -22898,7 +22898,7 @@
                 </a:solidFill>
                 <a:latin typeface="Segoe UI"/>
               </a:rPr>
-              <a:t>Registrar los 3 grupos de estudio:</a:t>
+              <a:t>Registrar los 3 roles normativos del campus:</a:t>
             </a:r>
           </a:p>
         </p:txBody>
@@ -23019,7 +23019,7 @@
                 </a:solidFill>
                 <a:latin typeface="Segoe UI"/>
               </a:rPr>
-              <a:t>Grupo 1</a:t>
+              <a:t>Rol Estudiante</a:t>
             </a:r>
           </a:p>
         </p:txBody>
@@ -23124,7 +23124,7 @@
                 </a:solidFill>
                 <a:latin typeface="Segoe UI"/>
               </a:rPr>
-              <a:t>Matemáticas</a:t>
+              <a:t>Reporta Incidencias</a:t>
             </a:r>
           </a:p>
         </p:txBody>
@@ -23245,7 +23245,7 @@
                 </a:solidFill>
                 <a:latin typeface="Segoe UI"/>
               </a:rPr>
-              <a:t>Grupo 2</a:t>
+              <a:t>Rol Técnico</a:t>
             </a:r>
           </a:p>
         </p:txBody>
@@ -23350,7 +23350,7 @@
                 </a:solidFill>
                 <a:latin typeface="Segoe UI"/>
               </a:rPr>
-              <a:t>Redes de Computadoras</a:t>
+              <a:t>Atiende Mantenimiento</a:t>
             </a:r>
           </a:p>
         </p:txBody>
@@ -23471,7 +23471,7 @@
                 </a:solidFill>
                 <a:latin typeface="Segoe UI"/>
               </a:rPr>
-              <a:t>Grupo 3</a:t>
+              <a:t>Rol Admin</a:t>
             </a:r>
           </a:p>
         </p:txBody>
@@ -23576,7 +23576,7 @@
                 </a:solidFill>
                 <a:latin typeface="Segoe UI"/>
               </a:rPr>
-              <a:t>Programación IV</a:t>
+              <a:t>Gestión de Infraestructura</a:t>
             </a:r>
           </a:p>
         </p:txBody>
@@ -23695,8 +23695,8 @@
   "usuario": {
     "id": 3,
     "nombre": "Carlos Méndez",
-    "email": "carlos.mendez@...",
-    "creadoEn": "2026-..."
+    "email": "carlos.mendez@upds.edu.bo",
+    "rol": "tecnico"
   }
 }</a:t>
             </a:r>
@@ -23733,7 +23733,7 @@
                 </a:solidFill>
                 <a:latin typeface="Segoe UI"/>
               </a:rPr>
-              <a:t>⚠️  El campo password NUNCA aparece en la respuesta</a:t>
+              <a:t>⚠️  El campo hashed_password NUNCA aparece en la respuesta (Filtrado por Pydantic DTO)</a:t>
             </a:r>
           </a:p>
         </p:txBody>
@@ -23849,7 +23849,7 @@
                 </a:solidFill>
                 <a:latin typeface="Segoe UI"/>
               </a:rPr>
-              <a:t>StudySync API  •  Programación IV — UPDS 2026  •  6/18</a:t>
+              <a:t>Issue Realtime  •  Programación IV — UPDS 2026  •  6/18</a:t>
             </a:r>
           </a:p>
         </p:txBody>
@@ -24031,7 +24031,7 @@
                 </a:solidFill>
                 <a:latin typeface="Segoe UI"/>
               </a:rPr>
-              <a:t>POST /auth/login → devuelve eyJhbGci... (JSON Web Token)</a:t>
+              <a:t>POST /auth/login → devuelve el access_token (JSON Web Token)</a:t>
             </a:r>
           </a:p>
         </p:txBody>
@@ -24518,7 +24518,7 @@
                 </a:solidFill>
                 <a:latin typeface="Segoe UI"/>
               </a:rPr>
-              <a:t>eyJpZCI6MSwiZW1haWwiOiIuLi4ifQ</a:t>
+              <a:t>eyJpZCI6MywiZW1haWwiOiIuLi4iLCJyb2wiOiIuLi4ifQ</a:t>
             </a:r>
           </a:p>
         </p:txBody>
@@ -24553,7 +24553,7 @@
                 </a:solidFill>
                 <a:latin typeface="Segoe UI"/>
               </a:rPr>
-              <a:t>→ Datos: id, email, nombre</a:t>
+              <a:t>→ Datos: id, email, nombre, rol</a:t>
             </a:r>
           </a:p>
         </p:txBody>
@@ -24701,7 +24701,7 @@
                 </a:solidFill>
                 <a:latin typeface="Segoe UI"/>
               </a:rPr>
-              <a:t>→ Firma con JWT_SECRET</a:t>
+              <a:t>→ Firma criptográfica con la SECRET_KEY del backend</a:t>
             </a:r>
           </a:p>
         </p:txBody>
@@ -25341,7 +25341,7 @@
                 </a:solidFill>
                 <a:latin typeface="Segoe UI"/>
               </a:rPr>
-              <a:t>StudySync API  •  Programación IV — UPDS 2026  •  7/18</a:t>
+              <a:t>Issue Realtime  •  Programación IV — UPDS 2026  •  7/18</a:t>
             </a:r>
           </a:p>
         </p:txBody>
@@ -25488,7 +25488,7 @@
                 </a:solidFill>
                 <a:latin typeface="Segoe UI"/>
               </a:rPr>
-              <a:t>Demo Paso 4 — Grupo 1: Ana Torres (Matemáticas)</a:t>
+              <a:t>Demo Paso 4 — Rol Estudiante: Ana Torres (Reporta Incidencias)</a:t>
             </a:r>
           </a:p>
         </p:txBody>
@@ -25601,7 +25601,7 @@
                 </a:solidFill>
                 <a:latin typeface="Segoe UI"/>
               </a:rPr>
-              <a:t>3 sesiones</a:t>
+              <a:t>3 reportes</a:t>
             </a:r>
           </a:p>
         </p:txBody>
@@ -25714,7 +25714,7 @@
                 </a:solidFill>
                 <a:latin typeface="Segoe UI"/>
               </a:rPr>
-              <a:t>Crear las 3 sesiones de Matemáticas:</a:t>
+              <a:t>Crear las 3 reportes de Reporta Incidencias:</a:t>
             </a:r>
           </a:p>
         </p:txBody>
@@ -25835,7 +25835,7 @@
                 </a:solidFill>
                 <a:latin typeface="Segoe UI"/>
               </a:rPr>
-              <a:t>#11</a:t>
+              <a:t>#1</a:t>
             </a:r>
           </a:p>
         </p:txBody>
@@ -25905,7 +25905,7 @@
                 </a:solidFill>
                 <a:latin typeface="Segoe UI"/>
               </a:rPr>
-              <a:t>Operaciones con matrices y determinantes</a:t>
+              <a:t>El equipo no enciende y presenta un goteo constante de agua</a:t>
             </a:r>
           </a:p>
         </p:txBody>
@@ -26026,7 +26026,7 @@
                 </a:solidFill>
                 <a:latin typeface="Segoe UI"/>
               </a:rPr>
-              <a:t>#12</a:t>
+              <a:t>#2</a:t>
             </a:r>
           </a:p>
         </p:txBody>
@@ -26096,7 +26096,7 @@
                 </a:solidFill>
                 <a:latin typeface="Segoe UI"/>
               </a:rPr>
-              <a:t>Espacios vectoriales y transformaciones lineales</a:t>
+              <a:t>Cables de red y de corriente sueltos detrás del rack principal</a:t>
             </a:r>
           </a:p>
         </p:txBody>
@@ -26217,7 +26217,7 @@
                 </a:solidFill>
                 <a:latin typeface="Segoe UI"/>
               </a:rPr>
-              <a:t>#13</a:t>
+              <a:t>#3</a:t>
             </a:r>
           </a:p>
         </p:txBody>
@@ -26287,7 +26287,7 @@
                 </a:solidFill>
                 <a:latin typeface="Segoe UI"/>
               </a:rPr>
-              <a:t>Repaso completo antes del parcial</a:t>
+              <a:t>La puerta de ingreso principal no cierra correctamente</a:t>
             </a:r>
           </a:p>
         </p:txBody>
@@ -26322,7 +26322,7 @@
                 </a:solidFill>
                 <a:latin typeface="Segoe UI"/>
               </a:rPr>
-              <a:t>Body JSON para cada sesión:</a:t>
+              <a:t>Formulario Multipart para cada reporte:</a:t>
             </a:r>
           </a:p>
         </p:txBody>
@@ -26484,9 +26484,9 @@
                 </a:solidFill>
                 <a:latin typeface="Segoe UI"/>
               </a:rPr>
-              <a:t>[ Captura: POST /api/sesiones con token
+              <a:t>[ Captura: POST /api/reportes con token
   y respuesta 201 mostrando
-  id, titulo, materia y autor ]</a:t>
+  id, titulo, estado, url_foto y usuario_id ]</a:t>
             </a:r>
           </a:p>
         </p:txBody>
@@ -26521,7 +26521,7 @@
                 </a:solidFill>
                 <a:latin typeface="Segoe UI"/>
               </a:rPr>
-              <a:t>StudySync API  •  Programación IV — UPDS 2026  •  8/18</a:t>
+              <a:t>Issue Realtime  •  Programación IV — UPDS 2026  •  8/18</a:t>
             </a:r>
           </a:p>
         </p:txBody>
@@ -26703,7 +26703,7 @@
                 </a:solidFill>
                 <a:latin typeface="Segoe UI"/>
               </a:rPr>
-              <a:t>Cada grupo con su propio token JWT</a:t>
+              <a:t>Cada rol con su propio token y alcances (RBAC)</a:t>
             </a:r>
           </a:p>
         </p:txBody>
@@ -26781,7 +26781,7 @@
                 </a:solidFill>
                 <a:latin typeface="Segoe UI"/>
               </a:rPr>
-              <a:t>6 sesiones más</a:t>
+              <a:t>6 acciones más</a:t>
             </a:r>
           </a:p>
         </p:txBody>
@@ -26937,7 +26937,7 @@
                 </a:solidFill>
                 <a:latin typeface="Segoe UI"/>
               </a:rPr>
-              <a:t>  Carlos Méndez — Redes de Computadoras</a:t>
+              <a:t>  Carlos Méndez — Atiende Mantenimiento</a:t>
             </a:r>
           </a:p>
         </p:txBody>
@@ -27058,7 +27058,7 @@
                 </a:solidFill>
                 <a:latin typeface="Segoe UI"/>
               </a:rPr>
-              <a:t>#5</a:t>
+              <a:t>#4</a:t>
             </a:r>
           </a:p>
         </p:txBody>
@@ -27128,7 +27128,7 @@
                 </a:solidFill>
                 <a:latin typeface="Segoe UI"/>
               </a:rPr>
-              <a:t>Las 7 capas del modelo OSI explicadas</a:t>
+              <a:t>Técnico asignado revisando el compresor en el aula</a:t>
             </a:r>
           </a:p>
         </p:txBody>
@@ -27249,7 +27249,7 @@
                 </a:solidFill>
                 <a:latin typeface="Segoe UI"/>
               </a:rPr>
-              <a:t>#6</a:t>
+              <a:t>#5</a:t>
             </a:r>
           </a:p>
         </p:txBody>
@@ -27319,7 +27319,7 @@
                 </a:solidFill>
                 <a:latin typeface="Segoe UI"/>
               </a:rPr>
-              <a:t>Cálculo de subredes IPv4</a:t>
+              <a:t>Reorganizando y aislando líneas de red expuestas</a:t>
             </a:r>
           </a:p>
         </p:txBody>
@@ -27440,7 +27440,7 @@
                 </a:solidFill>
                 <a:latin typeface="Segoe UI"/>
               </a:rPr>
-              <a:t>#7</a:t>
+              <a:t>#6</a:t>
             </a:r>
           </a:p>
         </p:txBody>
@@ -27510,7 +27510,7 @@
                 </a:solidFill>
                 <a:latin typeface="Segoe UI"/>
               </a:rPr>
-              <a:t>Configuración de routers y switches</a:t>
+              <a:t>"Se requiere cambio de capacitor eléctrico"</a:t>
             </a:r>
           </a:p>
         </p:txBody>
@@ -27588,7 +27588,7 @@
                 </a:solidFill>
                 <a:latin typeface="Segoe UI"/>
               </a:rPr>
-              <a:t>  Sofía Vargas — Programación IV</a:t>
+              <a:t>  Sofía Vargas — Gestión de Infraestructura</a:t>
             </a:r>
           </a:p>
         </p:txBody>
@@ -27709,7 +27709,7 @@
                 </a:solidFill>
                 <a:latin typeface="Segoe UI"/>
               </a:rPr>
-              <a:t>#8</a:t>
+              <a:t>#7</a:t>
             </a:r>
           </a:p>
         </p:txBody>
@@ -27779,7 +27779,7 @@
                 </a:solidFill>
                 <a:latin typeface="Segoe UI"/>
               </a:rPr>
-              <a:t>Construcción de APIs con Node.js</a:t>
+              <a:t>Cambio de chapa y picaporte completado con éxito</a:t>
             </a:r>
           </a:p>
         </p:txBody>
@@ -27900,7 +27900,7 @@
                 </a:solidFill>
                 <a:latin typeface="Segoe UI"/>
               </a:rPr>
-              <a:t>#9</a:t>
+              <a:t>#8</a:t>
             </a:r>
           </a:p>
         </p:txBody>
@@ -27935,7 +27935,7 @@
                 </a:solidFill>
                 <a:latin typeface="Segoe UI"/>
               </a:rPr>
-              <a:t>Prog IV — Prisma ORM y Supabase</a:t>
+              <a:t>Prog IV — SQLAlchemy ORM y Supabase PostgreSQL</a:t>
             </a:r>
           </a:p>
         </p:txBody>
@@ -27970,7 +27970,7 @@
                 </a:solidFill>
                 <a:latin typeface="Segoe UI"/>
               </a:rPr>
-              <a:t>Conexión a PostgreSQL con Prisma</a:t>
+              <a:t>Canaletas instaladas y cables sellados de forma segura</a:t>
             </a:r>
           </a:p>
         </p:txBody>
@@ -28091,7 +28091,7 @@
                 </a:solidFill>
                 <a:latin typeface="Segoe UI"/>
               </a:rPr>
-              <a:t>#10</a:t>
+              <a:t>#9</a:t>
             </a:r>
           </a:p>
         </p:txBody>
@@ -28126,7 +28126,7 @@
                 </a:solidFill>
                 <a:latin typeface="Segoe UI"/>
               </a:rPr>
-              <a:t>Prog IV — Redis PubSub y Socket.io</a:t>
+              <a:t>Prog IV — Redis PubSub y WebSockets Nativos</a:t>
             </a:r>
           </a:p>
         </p:txBody>
@@ -28161,7 +28161,7 @@
                 </a:solidFill>
                 <a:latin typeface="Segoe UI"/>
               </a:rPr>
-              <a:t>Mensajería en tiempo real</a:t>
+              <a:t>Disparo automático de la notificación de cierre de falla</a:t>
             </a:r>
           </a:p>
         </p:txBody>
@@ -28241,9 +28241,9 @@
                 </a:solidFill>
                 <a:latin typeface="Segoe UI"/>
               </a:rPr>
-              <a:t>[ Captura: GET /api/sesiones mostrando
-  las 12 sesiones de los 3 grupos
-  con autor incluido en cada una ]</a:t>
+              <a:t>[ Captura: GET /api/reportes mostrando
+  las incidencias actualizadas con historial
+  de estados y comentarios técnicos ]</a:t>
             </a:r>
           </a:p>
         </p:txBody>
@@ -28278,7 +28278,7 @@
                 </a:solidFill>
                 <a:latin typeface="Segoe UI"/>
               </a:rPr>
-              <a:t>StudySync API  •  Programación IV — UPDS 2026  •  9/18</a:t>
+              <a:t>Issue Realtime  •  Programación IV — UPDS 2026  •  9/18</a:t>
             </a:r>
           </a:p>
         </p:txBody>

</xml_diff>